<commit_message>
Refactor presentation deck generation and improve layout handling
- Removed unnecessary compiled Python files from the cache.
- Updated `make-deck.py` to dynamically calculate heading sizes based on character count, improving text fitting.
- Adjusted layout dimensions and spacing for various elements to enhance visual consistency.
- Modified `preview.py` to ensure proper CSS styling for slides, including width adjustments for better rendering.
</commit_message>
<xml_diff>
--- a/docs/stakeholder/OpenOKR-Deck.pptx
+++ b/docs/stakeholder/OpenOKR-Deck.pptx
@@ -617,7 +617,7 @@
         <p:spPr>
           <a:xfrm>
             <a:off x="711200" y="774700"/>
-            <a:ext cx="10769600" cy="508000"/>
+            <a:ext cx="10769600" cy="457200"/>
           </a:xfrm>
           <a:prstGeom prst="rect">
             <a:avLst/>
@@ -2588,7 +2588,7 @@
         <p:spPr>
           <a:xfrm>
             <a:off x="711200" y="774700"/>
-            <a:ext cx="10769600" cy="508000"/>
+            <a:ext cx="10769600" cy="457200"/>
           </a:xfrm>
           <a:prstGeom prst="rect">
             <a:avLst/>
@@ -4109,7 +4109,7 @@
         <p:spPr>
           <a:xfrm>
             <a:off x="711200" y="774700"/>
-            <a:ext cx="10769600" cy="508000"/>
+            <a:ext cx="10769600" cy="457200"/>
           </a:xfrm>
           <a:prstGeom prst="rect">
             <a:avLst/>
@@ -4718,7 +4718,7 @@
         <p:spPr>
           <a:xfrm>
             <a:off x="711200" y="774700"/>
-            <a:ext cx="10769600" cy="508000"/>
+            <a:ext cx="10769600" cy="457200"/>
           </a:xfrm>
           <a:prstGeom prst="rect">
             <a:avLst/>
@@ -4841,7 +4841,7 @@
         <p:spPr>
           <a:xfrm>
             <a:off x="1219200" y="1536700"/>
-            <a:ext cx="6604000" cy="279400"/>
+            <a:ext cx="5842000" cy="279400"/>
           </a:xfrm>
           <a:prstGeom prst="rect">
             <a:avLst/>
@@ -4964,7 +4964,7 @@
         <p:spPr>
           <a:xfrm>
             <a:off x="1219200" y="2044700"/>
-            <a:ext cx="6604000" cy="279400"/>
+            <a:ext cx="5842000" cy="279400"/>
           </a:xfrm>
           <a:prstGeom prst="rect">
             <a:avLst/>
@@ -5087,7 +5087,7 @@
         <p:spPr>
           <a:xfrm>
             <a:off x="1219200" y="2552700"/>
-            <a:ext cx="6604000" cy="279400"/>
+            <a:ext cx="5842000" cy="279400"/>
           </a:xfrm>
           <a:prstGeom prst="rect">
             <a:avLst/>
@@ -5210,7 +5210,7 @@
         <p:spPr>
           <a:xfrm>
             <a:off x="1219200" y="3060700"/>
-            <a:ext cx="6604000" cy="279400"/>
+            <a:ext cx="5842000" cy="279400"/>
           </a:xfrm>
           <a:prstGeom prst="rect">
             <a:avLst/>
@@ -5333,7 +5333,7 @@
         <p:spPr>
           <a:xfrm>
             <a:off x="1219200" y="3568700"/>
-            <a:ext cx="6604000" cy="279400"/>
+            <a:ext cx="5842000" cy="279400"/>
           </a:xfrm>
           <a:prstGeom prst="rect">
             <a:avLst/>
@@ -5456,7 +5456,7 @@
         <p:spPr>
           <a:xfrm>
             <a:off x="1219200" y="4076700"/>
-            <a:ext cx="6604000" cy="279400"/>
+            <a:ext cx="5842000" cy="279400"/>
           </a:xfrm>
           <a:prstGeom prst="rect">
             <a:avLst/>
@@ -5501,12 +5501,12 @@
         </p:nvSpPr>
         <p:spPr>
           <a:xfrm>
-            <a:off x="8280400" y="1485900"/>
-            <a:ext cx="3200400" cy="3124200"/>
+            <a:off x="7416800" y="1485900"/>
+            <a:ext cx="4064000" cy="3175000"/>
           </a:xfrm>
           <a:prstGeom prst="roundRect">
             <a:avLst>
-              <a:gd name="adj" fmla="val 3252"/>
+              <a:gd name="adj" fmla="val 3200"/>
             </a:avLst>
           </a:prstGeom>
           <a:solidFill>
@@ -5534,8 +5534,8 @@
         </p:nvSpPr>
         <p:spPr>
           <a:xfrm>
-            <a:off x="8585200" y="1816100"/>
-            <a:ext cx="2590800" cy="304800"/>
+            <a:off x="7721600" y="1790700"/>
+            <a:ext cx="3454400" cy="304800"/>
           </a:xfrm>
           <a:prstGeom prst="rect">
             <a:avLst/>
@@ -5580,8 +5580,8 @@
         </p:nvSpPr>
         <p:spPr>
           <a:xfrm>
-            <a:off x="8585200" y="2197100"/>
-            <a:ext cx="2590800" cy="2159000"/>
+            <a:off x="7721600" y="2171700"/>
+            <a:ext cx="3454400" cy="2286000"/>
           </a:xfrm>
           <a:prstGeom prst="rect">
             <a:avLst/>
@@ -5614,7 +5614,7 @@
                 <a:cs typeface="Calibri"/>
               </a:rPr>
               <a:t>Capacity is read from the initiatives actually planned against each key result, not self-declared.
-If one key result exceeds capacity and no cut is recorded, the cycle cannot be published.
+If one exceeds and no cut is recorded, the cycle cannot be published.
 </a:t>
             </a:r>
             <a:r>
@@ -5626,16 +5626,6 @@
                 <a:cs typeface="Calibri"/>
               </a:rPr>
               <a:t>A plan where nothing was cut is a plan that has not been made.</a:t>
-            </a:r>
-            <a:r>
-              <a:rPr lang="en-GB" sz="1200" b="0" dirty="0">
-                <a:solidFill>
-                  <a:srgbClr val="B45309"/>
-                </a:solidFill>
-                <a:latin typeface="Calibri"/>
-                <a:cs typeface="Calibri"/>
-              </a:rPr>
-              <a:t> Without the gate, the cut happens in week six instead, without a decision.</a:t>
             </a:r>
           </a:p>
         </p:txBody>
@@ -6669,7 +6659,7 @@
                 <a:latin typeface="Calibri"/>
                 <a:cs typeface="Calibri"/>
               </a:rPr>
-              <a:t>OPENOKR</a:t>
+              <a:t>THE PROBLEM</a:t>
             </a:r>
           </a:p>
         </p:txBody>
@@ -7789,7 +7779,7 @@
         <p:spPr>
           <a:xfrm>
             <a:off x="711200" y="774700"/>
-            <a:ext cx="10769600" cy="508000"/>
+            <a:ext cx="10769600" cy="457200"/>
           </a:xfrm>
           <a:prstGeom prst="rect">
             <a:avLst/>
@@ -9521,7 +9511,7 @@
         <p:spPr>
           <a:xfrm>
             <a:off x="711200" y="774700"/>
-            <a:ext cx="10769600" cy="508000"/>
+            <a:ext cx="10769600" cy="457200"/>
           </a:xfrm>
           <a:prstGeom prst="rect">
             <a:avLst/>
@@ -10633,7 +10623,7 @@
         <p:spPr>
           <a:xfrm>
             <a:off x="711200" y="774700"/>
-            <a:ext cx="10769600" cy="508000"/>
+            <a:ext cx="10769600" cy="457200"/>
           </a:xfrm>
           <a:prstGeom prst="rect">
             <a:avLst/>
@@ -11389,7 +11379,7 @@
         <p:spPr>
           <a:xfrm>
             <a:off x="711200" y="774700"/>
-            <a:ext cx="10769600" cy="508000"/>
+            <a:ext cx="10769600" cy="457200"/>
           </a:xfrm>
           <a:prstGeom prst="rect">
             <a:avLst/>
@@ -12373,7 +12363,7 @@
         <p:spPr>
           <a:xfrm>
             <a:off x="711200" y="774700"/>
-            <a:ext cx="10769600" cy="508000"/>
+            <a:ext cx="10769600" cy="457200"/>
           </a:xfrm>
           <a:prstGeom prst="rect">
             <a:avLst/>
@@ -12405,7 +12395,7 @@
                 <a:latin typeface="Calibri Light"/>
                 <a:cs typeface="Calibri Light"/>
               </a:rPr>
-              <a:t>Three ways to run OKRs today, three ways to lose the practice</a:t>
+              <a:t>How OKRs are run today, and why the practice still dies</a:t>
             </a:r>
           </a:p>
         </p:txBody>
@@ -12419,11 +12409,11 @@
         <p:spPr>
           <a:xfrm>
             <a:off x="711200" y="1485900"/>
-            <a:ext cx="3420533" cy="2667000"/>
+            <a:ext cx="3420533" cy="2133600"/>
           </a:xfrm>
           <a:prstGeom prst="roundRect">
             <a:avLst>
-              <a:gd name="adj" fmla="val 3809"/>
+              <a:gd name="adj" fmla="val 4761"/>
             </a:avLst>
           </a:prstGeom>
           <a:solidFill>
@@ -12459,7 +12449,7 @@
         <p:spPr>
           <a:xfrm>
             <a:off x="711200" y="1485900"/>
-            <a:ext cx="44450" cy="2667000"/>
+            <a:ext cx="44450" cy="2133600"/>
           </a:xfrm>
           <a:prstGeom prst="roundRect">
             <a:avLst>
@@ -12582,7 +12572,7 @@
         <p:spPr>
           <a:xfrm>
             <a:off x="939800" y="2197100"/>
-            <a:ext cx="2988733" cy="1778000"/>
+            <a:ext cx="2988733" cy="1244600"/>
           </a:xfrm>
           <a:prstGeom prst="rect">
             <a:avLst/>
@@ -12628,11 +12618,11 @@
         <p:spPr>
           <a:xfrm>
             <a:off x="4385733" y="1485900"/>
-            <a:ext cx="3420533" cy="2667000"/>
+            <a:ext cx="3420533" cy="2133600"/>
           </a:xfrm>
           <a:prstGeom prst="roundRect">
             <a:avLst>
-              <a:gd name="adj" fmla="val 3809"/>
+              <a:gd name="adj" fmla="val 4761"/>
             </a:avLst>
           </a:prstGeom>
           <a:solidFill>
@@ -12668,7 +12658,7 @@
         <p:spPr>
           <a:xfrm>
             <a:off x="4385733" y="1485900"/>
-            <a:ext cx="44450" cy="2667000"/>
+            <a:ext cx="44450" cy="2133600"/>
           </a:xfrm>
           <a:prstGeom prst="roundRect">
             <a:avLst>
@@ -12791,7 +12781,7 @@
         <p:spPr>
           <a:xfrm>
             <a:off x="4614333" y="2197100"/>
-            <a:ext cx="2988733" cy="1778000"/>
+            <a:ext cx="2988733" cy="1244600"/>
           </a:xfrm>
           <a:prstGeom prst="rect">
             <a:avLst/>
@@ -12837,11 +12827,11 @@
         <p:spPr>
           <a:xfrm>
             <a:off x="8060267" y="1485900"/>
-            <a:ext cx="3420533" cy="2667000"/>
+            <a:ext cx="3420533" cy="2133600"/>
           </a:xfrm>
           <a:prstGeom prst="roundRect">
             <a:avLst>
-              <a:gd name="adj" fmla="val 3809"/>
+              <a:gd name="adj" fmla="val 4761"/>
             </a:avLst>
           </a:prstGeom>
           <a:solidFill>
@@ -12877,7 +12867,7 @@
         <p:spPr>
           <a:xfrm>
             <a:off x="8060267" y="1485900"/>
-            <a:ext cx="44450" cy="2667000"/>
+            <a:ext cx="44450" cy="2133600"/>
           </a:xfrm>
           <a:prstGeom prst="roundRect">
             <a:avLst>
@@ -13000,7 +12990,7 @@
         <p:spPr>
           <a:xfrm>
             <a:off x="8288867" y="2197100"/>
-            <a:ext cx="2988733" cy="1778000"/>
+            <a:ext cx="2988733" cy="1244600"/>
           </a:xfrm>
           <a:prstGeom prst="rect">
             <a:avLst/>
@@ -13045,7 +13035,7 @@
         </p:nvSpPr>
         <p:spPr>
           <a:xfrm>
-            <a:off x="711200" y="4432300"/>
+            <a:off x="711200" y="3924300"/>
             <a:ext cx="10769600" cy="330200"/>
           </a:xfrm>
           <a:prstGeom prst="rect">
@@ -13153,7 +13143,7 @@
                 <a:latin typeface="Calibri"/>
                 <a:cs typeface="Calibri"/>
               </a:rPr>
-              <a:t>OPENOKR</a:t>
+              <a:t>THE PROBLEM</a:t>
             </a:r>
           </a:p>
         </p:txBody>
@@ -13617,7 +13607,7 @@
         <p:spPr>
           <a:xfrm>
             <a:off x="711200" y="774700"/>
-            <a:ext cx="10769600" cy="508000"/>
+            <a:ext cx="10769600" cy="457200"/>
           </a:xfrm>
           <a:prstGeom prst="rect">
             <a:avLst/>
@@ -13709,11 +13699,11 @@
         <p:spPr>
           <a:xfrm>
             <a:off x="711200" y="1866900"/>
-            <a:ext cx="3454400" cy="1752600"/>
+            <a:ext cx="3454400" cy="1930400"/>
           </a:xfrm>
           <a:prstGeom prst="roundRect">
             <a:avLst>
-              <a:gd name="adj" fmla="val 5797"/>
+              <a:gd name="adj" fmla="val 5263"/>
             </a:avLst>
           </a:prstGeom>
           <a:solidFill>
@@ -13865,7 +13855,7 @@
         <p:spPr>
           <a:xfrm>
             <a:off x="939800" y="2476500"/>
-            <a:ext cx="2997200" cy="1041400"/>
+            <a:ext cx="2997200" cy="1219200"/>
           </a:xfrm>
           <a:prstGeom prst="rect">
             <a:avLst/>
@@ -13911,11 +13901,11 @@
         <p:spPr>
           <a:xfrm>
             <a:off x="4368800" y="1866900"/>
-            <a:ext cx="3454400" cy="1752600"/>
+            <a:ext cx="3454400" cy="1930400"/>
           </a:xfrm>
           <a:prstGeom prst="roundRect">
             <a:avLst>
-              <a:gd name="adj" fmla="val 5797"/>
+              <a:gd name="adj" fmla="val 5263"/>
             </a:avLst>
           </a:prstGeom>
           <a:solidFill>
@@ -14067,7 +14057,7 @@
         <p:spPr>
           <a:xfrm>
             <a:off x="4597400" y="2476500"/>
-            <a:ext cx="2997200" cy="1041400"/>
+            <a:ext cx="2997200" cy="1219200"/>
           </a:xfrm>
           <a:prstGeom prst="rect">
             <a:avLst/>
@@ -14113,11 +14103,11 @@
         <p:spPr>
           <a:xfrm>
             <a:off x="8026400" y="1866900"/>
-            <a:ext cx="3454400" cy="1752600"/>
+            <a:ext cx="3454400" cy="1930400"/>
           </a:xfrm>
           <a:prstGeom prst="roundRect">
             <a:avLst>
-              <a:gd name="adj" fmla="val 5797"/>
+              <a:gd name="adj" fmla="val 5263"/>
             </a:avLst>
           </a:prstGeom>
           <a:solidFill>
@@ -14269,7 +14259,7 @@
         <p:spPr>
           <a:xfrm>
             <a:off x="8255000" y="2476500"/>
-            <a:ext cx="2997200" cy="1041400"/>
+            <a:ext cx="2997200" cy="1219200"/>
           </a:xfrm>
           <a:prstGeom prst="rect">
             <a:avLst/>
@@ -14314,12 +14304,12 @@
         </p:nvSpPr>
         <p:spPr>
           <a:xfrm>
-            <a:off x="711200" y="3771900"/>
-            <a:ext cx="3454400" cy="1752600"/>
+            <a:off x="711200" y="3949700"/>
+            <a:ext cx="3454400" cy="1930400"/>
           </a:xfrm>
           <a:prstGeom prst="roundRect">
             <a:avLst>
-              <a:gd name="adj" fmla="val 5797"/>
+              <a:gd name="adj" fmla="val 5263"/>
             </a:avLst>
           </a:prstGeom>
           <a:solidFill>
@@ -14347,7 +14337,7 @@
         </p:nvSpPr>
         <p:spPr>
           <a:xfrm>
-            <a:off x="939800" y="3975100"/>
+            <a:off x="939800" y="4152900"/>
             <a:ext cx="279400" cy="279400"/>
           </a:xfrm>
           <a:prstGeom prst="roundRect">
@@ -14378,7 +14368,7 @@
         </p:nvSpPr>
         <p:spPr>
           <a:xfrm>
-            <a:off x="939800" y="4038600"/>
+            <a:off x="939800" y="4216400"/>
             <a:ext cx="279400" cy="177800"/>
           </a:xfrm>
           <a:prstGeom prst="rect">
@@ -14424,7 +14414,7 @@
         </p:nvSpPr>
         <p:spPr>
           <a:xfrm>
-            <a:off x="1320800" y="4000500"/>
+            <a:off x="1320800" y="4178300"/>
             <a:ext cx="2616200" cy="228600"/>
           </a:xfrm>
           <a:prstGeom prst="rect">
@@ -14470,8 +14460,8 @@
         </p:nvSpPr>
         <p:spPr>
           <a:xfrm>
-            <a:off x="939800" y="4381500"/>
-            <a:ext cx="2997200" cy="1041400"/>
+            <a:off x="939800" y="4559300"/>
+            <a:ext cx="2997200" cy="1219200"/>
           </a:xfrm>
           <a:prstGeom prst="rect">
             <a:avLst/>
@@ -14516,12 +14506,12 @@
         </p:nvSpPr>
         <p:spPr>
           <a:xfrm>
-            <a:off x="4368800" y="3771900"/>
-            <a:ext cx="3454400" cy="1752600"/>
+            <a:off x="4368800" y="3949700"/>
+            <a:ext cx="3454400" cy="1930400"/>
           </a:xfrm>
           <a:prstGeom prst="roundRect">
             <a:avLst>
-              <a:gd name="adj" fmla="val 5797"/>
+              <a:gd name="adj" fmla="val 5263"/>
             </a:avLst>
           </a:prstGeom>
           <a:solidFill>
@@ -14549,7 +14539,7 @@
         </p:nvSpPr>
         <p:spPr>
           <a:xfrm>
-            <a:off x="4597400" y="3975100"/>
+            <a:off x="4597400" y="4152900"/>
             <a:ext cx="279400" cy="279400"/>
           </a:xfrm>
           <a:prstGeom prst="roundRect">
@@ -14580,7 +14570,7 @@
         </p:nvSpPr>
         <p:spPr>
           <a:xfrm>
-            <a:off x="4597400" y="4038600"/>
+            <a:off x="4597400" y="4216400"/>
             <a:ext cx="279400" cy="177800"/>
           </a:xfrm>
           <a:prstGeom prst="rect">
@@ -14626,7 +14616,7 @@
         </p:nvSpPr>
         <p:spPr>
           <a:xfrm>
-            <a:off x="4978400" y="4000500"/>
+            <a:off x="4978400" y="4178300"/>
             <a:ext cx="2616200" cy="228600"/>
           </a:xfrm>
           <a:prstGeom prst="rect">
@@ -14672,8 +14662,8 @@
         </p:nvSpPr>
         <p:spPr>
           <a:xfrm>
-            <a:off x="4597400" y="4381500"/>
-            <a:ext cx="2997200" cy="1041400"/>
+            <a:off x="4597400" y="4559300"/>
+            <a:ext cx="2997200" cy="1219200"/>
           </a:xfrm>
           <a:prstGeom prst="rect">
             <a:avLst/>
@@ -14718,12 +14708,12 @@
         </p:nvSpPr>
         <p:spPr>
           <a:xfrm>
-            <a:off x="8026400" y="3771900"/>
-            <a:ext cx="3454400" cy="1752600"/>
+            <a:off x="8026400" y="3949700"/>
+            <a:ext cx="3454400" cy="1930400"/>
           </a:xfrm>
           <a:prstGeom prst="roundRect">
             <a:avLst>
-              <a:gd name="adj" fmla="val 5797"/>
+              <a:gd name="adj" fmla="val 5263"/>
             </a:avLst>
           </a:prstGeom>
           <a:solidFill>
@@ -14751,7 +14741,7 @@
         </p:nvSpPr>
         <p:spPr>
           <a:xfrm>
-            <a:off x="8255000" y="3975100"/>
+            <a:off x="8255000" y="4152900"/>
             <a:ext cx="279400" cy="279400"/>
           </a:xfrm>
           <a:prstGeom prst="roundRect">
@@ -14782,7 +14772,7 @@
         </p:nvSpPr>
         <p:spPr>
           <a:xfrm>
-            <a:off x="8255000" y="4038600"/>
+            <a:off x="8255000" y="4216400"/>
             <a:ext cx="279400" cy="177800"/>
           </a:xfrm>
           <a:prstGeom prst="rect">
@@ -14828,7 +14818,7 @@
         </p:nvSpPr>
         <p:spPr>
           <a:xfrm>
-            <a:off x="8636000" y="4000500"/>
+            <a:off x="8636000" y="4178300"/>
             <a:ext cx="2616200" cy="228600"/>
           </a:xfrm>
           <a:prstGeom prst="rect">
@@ -14874,8 +14864,8 @@
         </p:nvSpPr>
         <p:spPr>
           <a:xfrm>
-            <a:off x="8255000" y="4381500"/>
-            <a:ext cx="2997200" cy="1041400"/>
+            <a:off x="8255000" y="4559300"/>
+            <a:ext cx="2997200" cy="1219200"/>
           </a:xfrm>
           <a:prstGeom prst="rect">
             <a:avLst/>
@@ -15142,7 +15132,7 @@
         <p:spPr>
           <a:xfrm>
             <a:off x="711200" y="774700"/>
-            <a:ext cx="10769600" cy="508000"/>
+            <a:ext cx="10769600" cy="457200"/>
           </a:xfrm>
           <a:prstGeom prst="rect">
             <a:avLst/>
@@ -16134,7 +16124,7 @@
         <p:spPr>
           <a:xfrm>
             <a:off x="711200" y="774700"/>
-            <a:ext cx="10769600" cy="508000"/>
+            <a:ext cx="10769600" cy="457200"/>
           </a:xfrm>
           <a:prstGeom prst="rect">
             <a:avLst/>
@@ -17855,7 +17845,7 @@
         <p:spPr>
           <a:xfrm>
             <a:off x="711200" y="774700"/>
-            <a:ext cx="10769600" cy="508000"/>
+            <a:ext cx="10769600" cy="457200"/>
           </a:xfrm>
           <a:prstGeom prst="rect">
             <a:avLst/>
@@ -18418,7 +18408,7 @@
         <p:spPr>
           <a:xfrm>
             <a:off x="711200" y="774700"/>
-            <a:ext cx="10769600" cy="508000"/>
+            <a:ext cx="10769600" cy="457200"/>
           </a:xfrm>
           <a:prstGeom prst="rect">
             <a:avLst/>
@@ -18464,11 +18454,11 @@
         <p:spPr>
           <a:xfrm>
             <a:off x="711200" y="1485900"/>
-            <a:ext cx="3437467" cy="3175000"/>
+            <a:ext cx="3437467" cy="3403600"/>
           </a:xfrm>
           <a:prstGeom prst="roundRect">
             <a:avLst>
-              <a:gd name="adj" fmla="val 3200"/>
+              <a:gd name="adj" fmla="val 2985"/>
             </a:avLst>
           </a:prstGeom>
           <a:solidFill>
@@ -18670,7 +18660,7 @@
         </p:nvSpPr>
         <p:spPr>
           <a:xfrm>
-            <a:off x="965200" y="3517900"/>
+            <a:off x="965200" y="3594100"/>
             <a:ext cx="2929467" cy="9525"/>
           </a:xfrm>
           <a:prstGeom prst="rect">
@@ -18699,7 +18689,7 @@
         </p:nvSpPr>
         <p:spPr>
           <a:xfrm>
-            <a:off x="965200" y="3695700"/>
+            <a:off x="965200" y="3771900"/>
             <a:ext cx="2929467" cy="177800"/>
           </a:xfrm>
           <a:prstGeom prst="rect">
@@ -18745,8 +18735,8 @@
         </p:nvSpPr>
         <p:spPr>
           <a:xfrm>
-            <a:off x="965200" y="3949700"/>
-            <a:ext cx="2929467" cy="965200"/>
+            <a:off x="965200" y="4025900"/>
+            <a:ext cx="2929467" cy="1016000"/>
           </a:xfrm>
           <a:prstGeom prst="rect">
             <a:avLst/>
@@ -18792,11 +18782,11 @@
         <p:spPr>
           <a:xfrm>
             <a:off x="4377267" y="1485900"/>
-            <a:ext cx="3437467" cy="3175000"/>
+            <a:ext cx="3437467" cy="3403600"/>
           </a:xfrm>
           <a:prstGeom prst="roundRect">
             <a:avLst>
-              <a:gd name="adj" fmla="val 3200"/>
+              <a:gd name="adj" fmla="val 2985"/>
             </a:avLst>
           </a:prstGeom>
           <a:solidFill>
@@ -18998,7 +18988,7 @@
         </p:nvSpPr>
         <p:spPr>
           <a:xfrm>
-            <a:off x="4631267" y="3517900"/>
+            <a:off x="4631267" y="3594100"/>
             <a:ext cx="2929467" cy="9525"/>
           </a:xfrm>
           <a:prstGeom prst="rect">
@@ -19027,7 +19017,7 @@
         </p:nvSpPr>
         <p:spPr>
           <a:xfrm>
-            <a:off x="4631267" y="3695700"/>
+            <a:off x="4631267" y="3771900"/>
             <a:ext cx="2929467" cy="177800"/>
           </a:xfrm>
           <a:prstGeom prst="rect">
@@ -19073,8 +19063,8 @@
         </p:nvSpPr>
         <p:spPr>
           <a:xfrm>
-            <a:off x="4631267" y="3949700"/>
-            <a:ext cx="2929467" cy="965200"/>
+            <a:off x="4631267" y="4025900"/>
+            <a:ext cx="2929467" cy="1016000"/>
           </a:xfrm>
           <a:prstGeom prst="rect">
             <a:avLst/>
@@ -19120,11 +19110,11 @@
         <p:spPr>
           <a:xfrm>
             <a:off x="8043333" y="1485900"/>
-            <a:ext cx="3437467" cy="3175000"/>
+            <a:ext cx="3437467" cy="3403600"/>
           </a:xfrm>
           <a:prstGeom prst="roundRect">
             <a:avLst>
-              <a:gd name="adj" fmla="val 3200"/>
+              <a:gd name="adj" fmla="val 2985"/>
             </a:avLst>
           </a:prstGeom>
           <a:solidFill>
@@ -19326,7 +19316,7 @@
         </p:nvSpPr>
         <p:spPr>
           <a:xfrm>
-            <a:off x="8297333" y="3517900"/>
+            <a:off x="8297333" y="3594100"/>
             <a:ext cx="2929467" cy="9525"/>
           </a:xfrm>
           <a:prstGeom prst="rect">
@@ -19355,7 +19345,7 @@
         </p:nvSpPr>
         <p:spPr>
           <a:xfrm>
-            <a:off x="8297333" y="3695700"/>
+            <a:off x="8297333" y="3771900"/>
             <a:ext cx="2929467" cy="177800"/>
           </a:xfrm>
           <a:prstGeom prst="rect">
@@ -19401,8 +19391,8 @@
         </p:nvSpPr>
         <p:spPr>
           <a:xfrm>
-            <a:off x="8297333" y="3949700"/>
-            <a:ext cx="2929467" cy="965200"/>
+            <a:off x="8297333" y="4025900"/>
+            <a:ext cx="2929467" cy="1016000"/>
           </a:xfrm>
           <a:prstGeom prst="rect">
             <a:avLst/>
@@ -19956,7 +19946,7 @@
         <p:spPr>
           <a:xfrm>
             <a:off x="711200" y="774700"/>
-            <a:ext cx="10769600" cy="508000"/>
+            <a:ext cx="10769600" cy="457200"/>
           </a:xfrm>
           <a:prstGeom prst="rect">
             <a:avLst/>
@@ -20480,7 +20470,7 @@
                 <a:latin typeface="Calibri"/>
                 <a:cs typeface="Calibri"/>
               </a:rPr>
-              <a:t>OPENOKR</a:t>
+              <a:t>THE PROBLEM</a:t>
             </a:r>
           </a:p>
         </p:txBody>
@@ -20944,7 +20934,7 @@
         <p:spPr>
           <a:xfrm>
             <a:off x="711200" y="774700"/>
-            <a:ext cx="10769600" cy="508000"/>
+            <a:ext cx="10769600" cy="457200"/>
           </a:xfrm>
           <a:prstGeom prst="rect">
             <a:avLst/>
@@ -21631,7 +21621,7 @@
         <p:spPr>
           <a:xfrm>
             <a:off x="711200" y="774700"/>
-            <a:ext cx="10769600" cy="508000"/>
+            <a:ext cx="10769600" cy="914400"/>
           </a:xfrm>
           <a:prstGeom prst="rect">
             <a:avLst/>
@@ -21676,7 +21666,7 @@
         </p:nvSpPr>
         <p:spPr>
           <a:xfrm>
-            <a:off x="711200" y="1282700"/>
+            <a:off x="711200" y="1739900"/>
             <a:ext cx="10007600" cy="431800"/>
           </a:xfrm>
           <a:prstGeom prst="rect">
@@ -21722,7 +21712,7 @@
         </p:nvSpPr>
         <p:spPr>
           <a:xfrm>
-            <a:off x="711200" y="1866900"/>
+            <a:off x="711200" y="2324100"/>
             <a:ext cx="2540000" cy="1219200"/>
           </a:xfrm>
           <a:prstGeom prst="roundRect">
@@ -21755,7 +21745,7 @@
         </p:nvSpPr>
         <p:spPr>
           <a:xfrm>
-            <a:off x="914400" y="2120900"/>
+            <a:off x="914400" y="2578100"/>
             <a:ext cx="2133600" cy="228600"/>
           </a:xfrm>
           <a:prstGeom prst="rect">
@@ -21801,7 +21791,7 @@
         </p:nvSpPr>
         <p:spPr>
           <a:xfrm>
-            <a:off x="914400" y="2400300"/>
+            <a:off x="914400" y="2857500"/>
             <a:ext cx="2133600" cy="558800"/>
           </a:xfrm>
           <a:prstGeom prst="rect">
@@ -21847,7 +21837,7 @@
         </p:nvSpPr>
         <p:spPr>
           <a:xfrm>
-            <a:off x="3454400" y="1866900"/>
+            <a:off x="3454400" y="2324100"/>
             <a:ext cx="2540000" cy="1219200"/>
           </a:xfrm>
           <a:prstGeom prst="roundRect">
@@ -21880,7 +21870,7 @@
         </p:nvSpPr>
         <p:spPr>
           <a:xfrm>
-            <a:off x="3657600" y="2120900"/>
+            <a:off x="3657600" y="2578100"/>
             <a:ext cx="2133600" cy="228600"/>
           </a:xfrm>
           <a:prstGeom prst="rect">
@@ -21926,7 +21916,7 @@
         </p:nvSpPr>
         <p:spPr>
           <a:xfrm>
-            <a:off x="3657600" y="2400300"/>
+            <a:off x="3657600" y="2857500"/>
             <a:ext cx="2133600" cy="558800"/>
           </a:xfrm>
           <a:prstGeom prst="rect">
@@ -21972,7 +21962,7 @@
         </p:nvSpPr>
         <p:spPr>
           <a:xfrm>
-            <a:off x="6197600" y="1866900"/>
+            <a:off x="6197600" y="2324100"/>
             <a:ext cx="2540000" cy="1219200"/>
           </a:xfrm>
           <a:prstGeom prst="roundRect">
@@ -22005,7 +21995,7 @@
         </p:nvSpPr>
         <p:spPr>
           <a:xfrm>
-            <a:off x="6400800" y="2120900"/>
+            <a:off x="6400800" y="2578100"/>
             <a:ext cx="2133600" cy="228600"/>
           </a:xfrm>
           <a:prstGeom prst="rect">
@@ -22051,7 +22041,7 @@
         </p:nvSpPr>
         <p:spPr>
           <a:xfrm>
-            <a:off x="6400800" y="2400300"/>
+            <a:off x="6400800" y="2857500"/>
             <a:ext cx="2133600" cy="558800"/>
           </a:xfrm>
           <a:prstGeom prst="rect">
@@ -22097,7 +22087,7 @@
         </p:nvSpPr>
         <p:spPr>
           <a:xfrm>
-            <a:off x="8940800" y="1866900"/>
+            <a:off x="8940800" y="2324100"/>
             <a:ext cx="2540000" cy="1219200"/>
           </a:xfrm>
           <a:prstGeom prst="roundRect">
@@ -22130,7 +22120,7 @@
         </p:nvSpPr>
         <p:spPr>
           <a:xfrm>
-            <a:off x="9144000" y="2120900"/>
+            <a:off x="9144000" y="2578100"/>
             <a:ext cx="2133600" cy="228600"/>
           </a:xfrm>
           <a:prstGeom prst="rect">
@@ -22176,7 +22166,7 @@
         </p:nvSpPr>
         <p:spPr>
           <a:xfrm>
-            <a:off x="9144000" y="2400300"/>
+            <a:off x="9144000" y="2857500"/>
             <a:ext cx="2133600" cy="558800"/>
           </a:xfrm>
           <a:prstGeom prst="rect">
@@ -22222,7 +22212,7 @@
         </p:nvSpPr>
         <p:spPr>
           <a:xfrm>
-            <a:off x="711200" y="3390900"/>
+            <a:off x="711200" y="3848100"/>
             <a:ext cx="10769600" cy="1041400"/>
           </a:xfrm>
           <a:prstGeom prst="roundRect">
@@ -22253,7 +22243,7 @@
         </p:nvSpPr>
         <p:spPr>
           <a:xfrm>
-            <a:off x="1016000" y="3644900"/>
+            <a:off x="1016000" y="4102100"/>
             <a:ext cx="10160000" cy="584200"/>
           </a:xfrm>
           <a:prstGeom prst="rect">
@@ -22521,7 +22511,7 @@
         <p:spPr>
           <a:xfrm>
             <a:off x="711200" y="774700"/>
-            <a:ext cx="10769600" cy="508000"/>
+            <a:ext cx="10769600" cy="457200"/>
           </a:xfrm>
           <a:prstGeom prst="rect">
             <a:avLst/>
@@ -23362,7 +23352,7 @@
         <p:spPr>
           <a:xfrm>
             <a:off x="711200" y="774700"/>
-            <a:ext cx="10769600" cy="508000"/>
+            <a:ext cx="10769600" cy="457200"/>
           </a:xfrm>
           <a:prstGeom prst="rect">
             <a:avLst/>

</xml_diff>